<commit_message>
Letzte Änderungen während des Kurses
</commit_message>
<xml_diff>
--- a/Einführung in R.pptx
+++ b/Einführung in R.pptx
@@ -350,7 +350,7 @@
           <a:p>
             <a:fld id="{3F46AE61-50B3-4440-BB01-1FF85E3E82A7}" type="datetimeFigureOut">
               <a:rPr lang="de-DE" smtClean="0"/>
-              <a:t>01.10.2024</a:t>
+              <a:t>02.10.2024</a:t>
             </a:fld>
             <a:endParaRPr lang="de-DE"/>
           </a:p>
@@ -540,7 +540,7 @@
           <a:p>
             <a:fld id="{3F46AE61-50B3-4440-BB01-1FF85E3E82A7}" type="datetimeFigureOut">
               <a:rPr lang="de-DE" smtClean="0"/>
-              <a:t>01.10.2024</a:t>
+              <a:t>02.10.2024</a:t>
             </a:fld>
             <a:endParaRPr lang="de-DE"/>
           </a:p>
@@ -720,7 +720,7 @@
           <a:p>
             <a:fld id="{3F46AE61-50B3-4440-BB01-1FF85E3E82A7}" type="datetimeFigureOut">
               <a:rPr lang="de-DE" smtClean="0"/>
-              <a:t>01.10.2024</a:t>
+              <a:t>02.10.2024</a:t>
             </a:fld>
             <a:endParaRPr lang="de-DE"/>
           </a:p>
@@ -890,7 +890,7 @@
           <a:p>
             <a:fld id="{3F46AE61-50B3-4440-BB01-1FF85E3E82A7}" type="datetimeFigureOut">
               <a:rPr lang="de-DE" smtClean="0"/>
-              <a:t>01.10.2024</a:t>
+              <a:t>02.10.2024</a:t>
             </a:fld>
             <a:endParaRPr lang="de-DE"/>
           </a:p>
@@ -1146,7 +1146,7 @@
           <a:p>
             <a:fld id="{3F46AE61-50B3-4440-BB01-1FF85E3E82A7}" type="datetimeFigureOut">
               <a:rPr lang="de-DE" smtClean="0"/>
-              <a:t>01.10.2024</a:t>
+              <a:t>02.10.2024</a:t>
             </a:fld>
             <a:endParaRPr lang="de-DE"/>
           </a:p>
@@ -1434,7 +1434,7 @@
           <a:p>
             <a:fld id="{3F46AE61-50B3-4440-BB01-1FF85E3E82A7}" type="datetimeFigureOut">
               <a:rPr lang="de-DE" smtClean="0"/>
-              <a:t>01.10.2024</a:t>
+              <a:t>02.10.2024</a:t>
             </a:fld>
             <a:endParaRPr lang="de-DE"/>
           </a:p>
@@ -1872,7 +1872,7 @@
           <a:p>
             <a:fld id="{3F46AE61-50B3-4440-BB01-1FF85E3E82A7}" type="datetimeFigureOut">
               <a:rPr lang="de-DE" smtClean="0"/>
-              <a:t>01.10.2024</a:t>
+              <a:t>02.10.2024</a:t>
             </a:fld>
             <a:endParaRPr lang="de-DE"/>
           </a:p>
@@ -1990,7 +1990,7 @@
           <a:p>
             <a:fld id="{3F46AE61-50B3-4440-BB01-1FF85E3E82A7}" type="datetimeFigureOut">
               <a:rPr lang="de-DE" smtClean="0"/>
-              <a:t>01.10.2024</a:t>
+              <a:t>02.10.2024</a:t>
             </a:fld>
             <a:endParaRPr lang="de-DE"/>
           </a:p>
@@ -2085,7 +2085,7 @@
           <a:p>
             <a:fld id="{3F46AE61-50B3-4440-BB01-1FF85E3E82A7}" type="datetimeFigureOut">
               <a:rPr lang="de-DE" smtClean="0"/>
-              <a:t>01.10.2024</a:t>
+              <a:t>02.10.2024</a:t>
             </a:fld>
             <a:endParaRPr lang="de-DE"/>
           </a:p>
@@ -2441,7 +2441,7 @@
           <a:p>
             <a:fld id="{3F46AE61-50B3-4440-BB01-1FF85E3E82A7}" type="datetimeFigureOut">
               <a:rPr lang="de-DE" smtClean="0"/>
-              <a:t>01.10.2024</a:t>
+              <a:t>02.10.2024</a:t>
             </a:fld>
             <a:endParaRPr lang="de-DE"/>
           </a:p>
@@ -2757,7 +2757,7 @@
           <a:p>
             <a:fld id="{3F46AE61-50B3-4440-BB01-1FF85E3E82A7}" type="datetimeFigureOut">
               <a:rPr lang="de-DE" smtClean="0"/>
-              <a:t>01.10.2024</a:t>
+              <a:t>02.10.2024</a:t>
             </a:fld>
             <a:endParaRPr lang="de-DE"/>
           </a:p>
@@ -2990,7 +2990,7 @@
           <a:p>
             <a:fld id="{3F46AE61-50B3-4440-BB01-1FF85E3E82A7}" type="datetimeFigureOut">
               <a:rPr lang="de-DE" smtClean="0"/>
-              <a:t>01.10.2024</a:t>
+              <a:t>02.10.2024</a:t>
             </a:fld>
             <a:endParaRPr lang="de-DE"/>
           </a:p>
@@ -12828,7 +12828,7 @@
             </a:r>
             <a:r>
               <a:rPr lang="de-DE" sz="2800" dirty="0"/>
-              <a:t>-Schleife die die Fibonacci Folge berechnet bis die aktuelle Zahl größer ist als 100</a:t>
+              <a:t>-Schleife die die Fibonacci Folge berechnet bis die neue Zahl größer ist als 100</a:t>
             </a:r>
           </a:p>
           <a:p>
@@ -12841,7 +12841,7 @@
             </a:pPr>
             <a:r>
               <a:rPr lang="de-DE" sz="2800" dirty="0"/>
-              <a:t>Wie groß ist die aktuelle Zahl?</a:t>
+              <a:t>Wie groß ist die neue Zahl?</a:t>
             </a:r>
           </a:p>
           <a:p>
@@ -12854,7 +12854,7 @@
             </a:pPr>
             <a:r>
               <a:rPr lang="de-DE" sz="2800" dirty="0"/>
-              <a:t>Wie viele Iterationen braucht die Folge bis die aktuelle Zahl größer ist als 100?</a:t>
+              <a:t>Wie viele Iterationen braucht die Folge bis die neue Zahl größer ist als 100?</a:t>
             </a:r>
           </a:p>
           <a:p>
@@ -12888,7 +12888,7 @@
             </a:pPr>
             <a:r>
               <a:rPr lang="de-DE" sz="2800" dirty="0"/>
-              <a:t>Wie groß ist die Zahl nach 100 Iterationen</a:t>
+              <a:t>Wie groß ist die neue Zahl nach 100 Iterationen</a:t>
             </a:r>
           </a:p>
         </p:txBody>
@@ -13048,7 +13048,7 @@
             </a:pPr>
             <a:r>
               <a:rPr lang="de-DE" sz="2800" dirty="0"/>
-              <a:t>	-&gt; ansonsten soll der nächste Wert berechnet werden aus dem vorherigen 		Wert – 3</a:t>
+              <a:t>	-&gt; ansonsten soll der nächste Wert berechnet werden aus dem vorherigen 		Wert – 2</a:t>
             </a:r>
           </a:p>
           <a:p>

</xml_diff>